<commit_message>
feat: initializing database script and improving neo4j graph
</commit_message>
<xml_diff>
--- a/exports/pitchbooks/AAPL_Institutional_Pitchbook.pptx
+++ b/exports/pitchbooks/AAPL_Institutional_Pitchbook.pptx
@@ -3146,7 +3146,7 @@
               </a:defRPr>
             </a:pPr>
             <a:r>
-              <a:t>Automated Swarm Analysis &amp; Financial Valuation Deck | August 18, 2026</a:t>
+              <a:t>Automated Swarm Analysis &amp; Financial Valuation Deck | August 19, 2026</a:t>
             </a:r>
           </a:p>
         </p:txBody>
@@ -3250,7 +3250,7 @@
             </a:r>
             <a:br/>
             <a:r>
-              <a:t>Key Profile: Leading Tech Company</a:t>
+              <a:t>Key Profile: SEC EDGAR Company profile and CIK mapping resource for ticker: AAPL</a:t>
             </a:r>
             <a:br/>
             <a:r>
@@ -3439,7 +3439,7 @@
                         </a:defRPr>
                       </a:pPr>
                       <a:r>
-                        <a:t>25.0%</a:t>
+                        <a:t>24.6%</a:t>
                       </a:r>
                     </a:p>
                   </a:txBody>
@@ -3498,7 +3498,7 @@
                         </a:defRPr>
                       </a:pPr>
                       <a:r>
-                        <a:t>Nonex</a:t>
+                        <a:t>28.4x</a:t>
                       </a:r>
                     </a:p>
                   </a:txBody>
@@ -3557,7 +3557,7 @@
                         </a:defRPr>
                       </a:pPr>
                       <a:r>
-                        <a:t>Nonex</a:t>
+                        <a:t>22.1x</a:t>
                       </a:r>
                     </a:p>
                   </a:txBody>
@@ -3741,7 +3741,7 @@
               </a:defRPr>
             </a:pPr>
             <a:r>
-              <a:t>Direction: NEUTRAL_STABILITY | Momentum Score: 0.0</a:t>
+              <a:t>Direction: BULLISH_EXPANSION | Momentum Score: 0.72</a:t>
             </a:r>
           </a:p>
           <a:p>
@@ -3874,11 +3874,11 @@
               </a:defRPr>
             </a:pPr>
             <a:r>
-              <a:t>• Graph Nodes Committed: 2</a:t>
+              <a:t>• Graph Nodes Committed: 1</a:t>
             </a:r>
             <a:br/>
             <a:r>
-              <a:t>• Relationships Built: 1</a:t>
+              <a:t>• Relationships Built: 0</a:t>
             </a:r>
             <a:br/>
             <a:r>

</xml_diff>